<commit_message>
Zielcheck statt „Heute habe ich gelernt“, Prüf-Kette statt Kreide-Kette (Mi 4.11. und Kurzeinheit angepasst)
Co-Authored-By: Claude Opus 5.5 <noreply@anthropic.com>
Claude-Session: https://claude.ai/code/session_01KXvLXHMYPnCyEbMRgNaaYs
</commit_message>
<xml_diff>
--- a/Deutsch_7A/Balladen/Woche2/Mittwoch_04-11_Deutsch_7A.pptx
+++ b/Deutsch_7A/Balladen/Woche2/Mittwoch_04-11_Deutsch_7A.pptx
@@ -20,9 +20,10 @@
     <p:sldId id="268" r:id="rId14"/>
     <p:sldId id="269" r:id="rId15"/>
     <p:sldId id="270" r:id="rId16"/>
+    <p:sldId id="271" r:id="rId17"/>
   </p:sldIdLst>
   <p:notesMasterIdLst>
-    <p:notesMasterId r:id="rId17"/>
+    <p:notesMasterId r:id="rId18"/>
   </p:notesMasterIdLst>
   <p:sldSz cx="12192000" cy="6858000"/>
   <p:notesSz cx="6858000" cy="12192000"/>
@@ -780,7 +781,7 @@
           <a:p>
             <a:r>
               <a:rPr lang="en-US" dirty="0"/>
-              <a:t>Lösung: 1 Ich trainiere heute länger, weil am Samstag ein Wettkampf ist. 2 Der Trainer sagt, dass wir nach Frankfurt (Oder) fahren. 3 Ich war nervös, als ich auf der Matte stand. 4 Wir gewinnen, wenn wir als Team spielen. 5 Ich bin stolz, weil ich 80 kg gestoßen habe. *6 Der Trainer fragt, ob ich gut geschlafen habe. Vergleich in der Kreide-Kette: Wer drankommt, schreibt einen Satz an, alle prüfen mit.</a:t>
+              <a:t>Lösung: 1 Ich trainiere heute länger, weil am Samstag ein Wettkampf ist. 2 Der Trainer sagt, dass wir nach Frankfurt (Oder) fahren. 3 Ich war nervös, als ich auf der Matte stand. 4 Wir gewinnen, wenn wir als Team spielen. 5 Ich bin stolz, weil ich 80 kg gestoßen habe. *6 Der Trainer fragt, ob ich gut geschlafen habe. Prüf-Kette: S1 schreibt Satz 1 an. S2 prüft ihn (✓/✗ + Begründung: Verb am Ende? Komma?) und schreibt Satz 2 usw. Alle anderen vergleichen mit ihrem Heft und verbessern mit Grün.</a:t>
             </a:r>
             <a:endParaRPr lang="en-US" dirty="0"/>
           </a:p>
@@ -1044,7 +1045,7 @@
           <a:p>
             <a:r>
               <a:rPr lang="en-US" dirty="0"/>
-              <a:t>Kurz die Forscherfrage stellen (*): In Str. 3 steht „als er stapfte durch den Sund“ – das Verb steht nicht am Ende. Warum? Wegen Reim und Rhythmus (Sund – stund): Dichter dürfen von der Regel abweichen. Im Aufsatz gilt die Regel. Dann „Heute habe ich gelernt, …“ ins Heft, zwei Schüler lesen vor.</a:t>
+              <a:t>Erst (*) Forscherfrage mündlich: In Str. 3 steht „als er stapfte durch den Sund“ – das Verb steht nicht am Ende, wegen Reim und Rhythmus (Sund – stund). Dichter dürfen abweichen, im Aufsatz gilt die Regel. Dann Zielcheck allein im Heft (4 Min.), danach Lösungsfolie: Selbstkontrolle mit Grün. Herumgehen und schauen, wer noch Fehler hat – am Donnerstag in der Wiederholung aufgreifen.</a:t>
             </a:r>
             <a:endParaRPr lang="en-US" dirty="0"/>
           </a:p>
@@ -1068,6 +1069,94 @@
             <a:fld id="{F7021451-1387-4CA6-816F-3879F97B5CBC}" type="slidenum">
               <a:rPr lang="en-US"/>
               <a:t>15</a:t>
+            </a:fld>
+            <a:endParaRPr lang="en-US"/>
+          </a:p>
+        </p:txBody>
+      </p:sp>
+    </p:spTree>
+    <p:extLst>
+      <p:ext uri="{BB962C8B-B14F-4D97-AF65-F5344CB8AC3E}">
+        <p14:creationId xmlns:p14="http://schemas.microsoft.com/office/powerpoint/2010/main" val="1024086991"/>
+      </p:ext>
+    </p:extLst>
+  </p:cSld>
+  <p:clrMapOvr>
+    <a:masterClrMapping/>
+  </p:clrMapOvr>
+</p:notes>
+</file>
+
+<file path=ppt/notesSlides/notesSlide16.xml><?xml version="1.0" encoding="utf-8"?>
+<p:notes xmlns:a="http://schemas.openxmlformats.org/drawingml/2006/main" xmlns:r="http://schemas.openxmlformats.org/officeDocument/2006/relationships" xmlns:p="http://schemas.openxmlformats.org/presentationml/2006/main">
+  <p:cSld>
+    <p:spTree>
+      <p:nvGrpSpPr>
+        <p:cNvPr id="1" name=""/>
+        <p:cNvGrpSpPr/>
+        <p:nvPr/>
+      </p:nvGrpSpPr>
+      <p:grpSpPr>
+        <a:xfrm>
+          <a:off x="0" y="0"/>
+          <a:ext cx="0" cy="0"/>
+          <a:chOff x="0" y="0"/>
+          <a:chExt cx="0" cy="0"/>
+        </a:xfrm>
+      </p:grpSpPr>
+      <p:sp>
+        <p:nvSpPr>
+          <p:cNvPr id="2" name="Slide Image Placeholder 1"/>
+          <p:cNvSpPr>
+            <a:spLocks noGrp="1" noRot="1" noChangeAspect="1"/>
+          </p:cNvSpPr>
+          <p:nvPr>
+            <p:ph type="sldImg"/>
+          </p:nvPr>
+        </p:nvSpPr>
+        <p:spPr/>
+      </p:sp>
+      <p:sp>
+        <p:nvSpPr>
+          <p:cNvPr id="3" name="Notes Placeholder 2"/>
+          <p:cNvSpPr>
+            <a:spLocks noGrp="1"/>
+          </p:cNvSpPr>
+          <p:nvPr>
+            <p:ph type="body" idx="1"/>
+          </p:nvPr>
+        </p:nvSpPr>
+        <p:spPr/>
+        <p:txBody>
+          <a:bodyPr/>
+          <a:lstStyle/>
+          <a:p>
+            <a:r>
+              <a:rPr lang="en-US" dirty="0"/>
+              <a:t>Mit Grün verbessern. Wer bei 2 a oder 2 b einen Fehler hat, schaut sich den Merksatz noch einmal an. Am Donnerstag beginnt die Wiederholung genau mit diesen Fehlern.</a:t>
+            </a:r>
+            <a:endParaRPr lang="en-US" dirty="0"/>
+          </a:p>
+        </p:txBody>
+      </p:sp>
+      <p:sp>
+        <p:nvSpPr>
+          <p:cNvPr id="4" name="Slide Number Placeholder 3"/>
+          <p:cNvSpPr>
+            <a:spLocks noGrp="1"/>
+          </p:cNvSpPr>
+          <p:nvPr>
+            <p:ph type="sldNum" sz="quarter" idx="10"/>
+          </p:nvPr>
+        </p:nvSpPr>
+        <p:spPr/>
+        <p:txBody>
+          <a:bodyPr/>
+          <a:lstStyle/>
+          <a:p>
+            <a:fld id="{F7021451-1387-4CA6-816F-3879F97B5CBC}" type="slidenum">
+              <a:rPr lang="en-US"/>
+              <a:t>16</a:t>
             </a:fld>
             <a:endParaRPr lang="en-US"/>
           </a:p>
@@ -1484,7 +1573,7 @@
           <a:p>
             <a:r>
               <a:rPr lang="en-US" dirty="0"/>
-              <a:t>Drei Schüler schreiben je eine Antwort in Stichworten mit Strophe an die Tafel. Alle prüfen mit und verbessern mit Grün. Bei Frage 3 nachfragen: Welche Lesetechnik hast du gebraucht? (genau). Lösungen siehe Folie davor.</a:t>
+              <a:t>Ablauf: S1 schreibt Antwort 1 in Stichworten mit Strophe an. S2 prüft sie zuerst (✓ oder ✗ + Stichwort zur Begründung) und schreibt dann Antwort 2. S3 prüft 2 und schreibt 3. S4 prüft 3. Alle anderen vergleichen mit ihrem Heft und verbessern mit Grün. Lösungen siehe Folie davor.</a:t>
             </a:r>
             <a:endParaRPr lang="en-US" dirty="0"/>
           </a:p>
@@ -7007,7 +7096,7 @@
                 <a:ea typeface="Cambria" pitchFamily="34" charset="-122"/>
                 <a:cs typeface="Cambria" pitchFamily="34" charset="-120"/>
               </a:rPr>
-              <a:t>Ziel erreicht?</a:t>
+              <a:t>Zielcheck: Hast du die Ziele erreicht?</a:t>
             </a:r>
             <a:endParaRPr lang="en-US" sz="3200" dirty="0"/>
           </a:p>
@@ -7099,12 +7188,87 @@
         </p:nvSpPr>
         <p:spPr>
           <a:xfrm>
-            <a:off x="548640" y="1463040"/>
-            <a:ext cx="11064240" cy="822960"/>
+            <a:off x="548640" y="1417320"/>
+            <a:ext cx="11064240" cy="777240"/>
           </a:xfrm>
           <a:prstGeom prst="roundRect">
             <a:avLst>
-              <a:gd name="adj" fmla="val 8889"/>
+              <a:gd name="adj" fmla="val 9412"/>
+            </a:avLst>
+          </a:prstGeom>
+          <a:solidFill>
+            <a:srgbClr val="EAF0FA"/>
+          </a:solidFill>
+          <a:ln/>
+        </p:spPr>
+      </p:sp>
+      <p:sp>
+        <p:nvSpPr>
+          <p:cNvPr id="8" name="Text 5"/>
+          <p:cNvSpPr txBox="1"/>
+          <p:nvPr/>
+        </p:nvSpPr>
+        <p:spPr>
+          <a:xfrm>
+            <a:off x="822960" y="1554480"/>
+            <a:ext cx="10607040" cy="548640"/>
+          </a:xfrm>
+          <a:prstGeom prst="rect">
+            <a:avLst/>
+          </a:prstGeom>
+          <a:noFill/>
+          <a:ln/>
+        </p:spPr>
+        <p:txBody>
+          <a:bodyPr wrap="square" lIns="0" tIns="0" rIns="0" bIns="0" rtlCol="0" anchor="t"/>
+          <a:lstStyle/>
+          <a:p>
+            <a:pPr indent="0" marL="0">
+              <a:buNone/>
+            </a:pPr>
+            <a:r>
+              <a:rPr lang="en-US" sz="1800" b="1" dirty="0">
+                <a:solidFill>
+                  <a:srgbClr val="7A5BA6"/>
+                </a:solidFill>
+                <a:latin typeface="Calibri" pitchFamily="34" charset="0"/>
+                <a:ea typeface="Calibri" pitchFamily="34" charset="-122"/>
+                <a:cs typeface="Calibri" pitchFamily="34" charset="-120"/>
+              </a:rPr>
+              <a:t>* Forscherfrage: </a:t>
+            </a:r>
+            <a:pPr indent="0" marL="0">
+              <a:buNone/>
+            </a:pPr>
+            <a:r>
+              <a:rPr lang="en-US" sz="1800" dirty="0">
+                <a:solidFill>
+                  <a:srgbClr val="1E2761"/>
+                </a:solidFill>
+                <a:latin typeface="Calibri" pitchFamily="34" charset="0"/>
+                <a:ea typeface="Calibri" pitchFamily="34" charset="-122"/>
+                <a:cs typeface="Calibri" pitchFamily="34" charset="-120"/>
+              </a:rPr>
+              <a:t>Str. 3: „Und als er stapfte durch den Sund“ – was ist hier anders, und warum?</a:t>
+            </a:r>
+            <a:endParaRPr lang="en-US" sz="1800" dirty="0"/>
+          </a:p>
+        </p:txBody>
+      </p:sp>
+      <p:sp>
+        <p:nvSpPr>
+          <p:cNvPr id="9" name="Shape 6"/>
+          <p:cNvSpPr/>
+          <p:nvPr/>
+        </p:nvSpPr>
+        <p:spPr>
+          <a:xfrm>
+            <a:off x="548640" y="2468880"/>
+            <a:ext cx="11064240" cy="777240"/>
+          </a:xfrm>
+          <a:prstGeom prst="roundRect">
+            <a:avLst>
+              <a:gd name="adj" fmla="val 9412"/>
             </a:avLst>
           </a:prstGeom>
           <a:solidFill>
@@ -7115,14 +7279,14 @@
       </p:sp>
       <p:sp>
         <p:nvSpPr>
-          <p:cNvPr id="8" name="Shape 5"/>
+          <p:cNvPr id="10" name="Shape 7"/>
           <p:cNvSpPr/>
           <p:nvPr/>
         </p:nvSpPr>
         <p:spPr>
           <a:xfrm>
-            <a:off x="548640" y="1463040"/>
-            <a:ext cx="109728" cy="822960"/>
+            <a:off x="548640" y="2468880"/>
+            <a:ext cx="109728" cy="777240"/>
           </a:xfrm>
           <a:prstGeom prst="rect">
             <a:avLst/>
@@ -7135,30 +7299,30 @@
       </p:sp>
       <p:sp>
         <p:nvSpPr>
-          <p:cNvPr id="9" name="Text 6"/>
-          <p:cNvSpPr txBox="1"/>
-          <p:nvPr/>
-        </p:nvSpPr>
-        <p:spPr>
-          <a:xfrm>
-            <a:off x="868680" y="1645920"/>
-            <a:ext cx="10515600" cy="548640"/>
-          </a:xfrm>
-          <a:prstGeom prst="rect">
-            <a:avLst/>
-          </a:prstGeom>
-          <a:noFill/>
-          <a:ln/>
-        </p:spPr>
-        <p:txBody>
-          <a:bodyPr wrap="square" lIns="0" tIns="0" rIns="0" bIns="0" rtlCol="0" anchor="t"/>
-          <a:lstStyle/>
-          <a:p>
-            <a:pPr indent="0" marL="0">
-              <a:buNone/>
-            </a:pPr>
-            <a:r>
-              <a:rPr lang="en-US" sz="1800" b="1" dirty="0">
+          <p:cNvPr id="11" name="Text 8"/>
+          <p:cNvSpPr txBox="1"/>
+          <p:nvPr/>
+        </p:nvSpPr>
+        <p:spPr>
+          <a:xfrm>
+            <a:off x="868680" y="2651760"/>
+            <a:ext cx="10515600" cy="502920"/>
+          </a:xfrm>
+          <a:prstGeom prst="rect">
+            <a:avLst/>
+          </a:prstGeom>
+          <a:noFill/>
+          <a:ln/>
+        </p:spPr>
+        <p:txBody>
+          <a:bodyPr wrap="square" lIns="0" tIns="0" rIns="0" bIns="0" rtlCol="0" anchor="t"/>
+          <a:lstStyle/>
+          <a:p>
+            <a:pPr indent="0" marL="0">
+              <a:buNone/>
+            </a:pPr>
+            <a:r>
+              <a:rPr lang="en-US" sz="1900" b="1" dirty="0">
                 <a:solidFill>
                   <a:srgbClr val="2E9E6B"/>
                 </a:solidFill>
@@ -7166,13 +7330,13 @@
                 <a:ea typeface="Calibri" pitchFamily="34" charset="-122"/>
                 <a:cs typeface="Calibri" pitchFamily="34" charset="-120"/>
               </a:rPr>
-              <a:t>Teil 1:  </a:t>
-            </a:r>
-            <a:pPr indent="0" marL="0">
-              <a:buNone/>
-            </a:pPr>
-            <a:r>
-              <a:rPr lang="en-US" sz="1800" i="1" dirty="0">
+              <a:t>Ziel 1:  </a:t>
+            </a:r>
+            <a:pPr indent="0" marL="0">
+              <a:buNone/>
+            </a:pPr>
+            <a:r>
+              <a:rPr lang="en-US" sz="1900" dirty="0">
                 <a:solidFill>
                   <a:srgbClr val="1E2761"/>
                 </a:solidFill>
@@ -7180,26 +7344,26 @@
                 <a:ea typeface="Calibri" pitchFamily="34" charset="-122"/>
                 <a:cs typeface="Calibri" pitchFamily="34" charset="-120"/>
               </a:rPr>
-              <a:t>Ich kann Fragen zum Inhalt der Ballade mit Textbeleg beantworten.</a:t>
-            </a:r>
-            <a:endParaRPr lang="en-US" sz="1800" dirty="0"/>
-          </a:p>
-        </p:txBody>
-      </p:sp>
-      <p:sp>
-        <p:nvSpPr>
-          <p:cNvPr id="10" name="Shape 7"/>
+              <a:t>Beantworte mit Strophe: Warum flieht der Schotte am Ende?</a:t>
+            </a:r>
+            <a:endParaRPr lang="en-US" sz="1900" dirty="0"/>
+          </a:p>
+        </p:txBody>
+      </p:sp>
+      <p:sp>
+        <p:nvSpPr>
+          <p:cNvPr id="12" name="Shape 9"/>
           <p:cNvSpPr/>
           <p:nvPr/>
         </p:nvSpPr>
         <p:spPr>
           <a:xfrm>
-            <a:off x="548640" y="2423160"/>
-            <a:ext cx="11064240" cy="822960"/>
+            <a:off x="548640" y="3383280"/>
+            <a:ext cx="11064240" cy="777240"/>
           </a:xfrm>
           <a:prstGeom prst="roundRect">
             <a:avLst>
-              <a:gd name="adj" fmla="val 8889"/>
+              <a:gd name="adj" fmla="val 9412"/>
             </a:avLst>
           </a:prstGeom>
           <a:solidFill>
@@ -7210,14 +7374,14 @@
       </p:sp>
       <p:sp>
         <p:nvSpPr>
-          <p:cNvPr id="11" name="Shape 8"/>
+          <p:cNvPr id="13" name="Shape 10"/>
           <p:cNvSpPr/>
           <p:nvPr/>
         </p:nvSpPr>
         <p:spPr>
           <a:xfrm>
-            <a:off x="548640" y="2423160"/>
-            <a:ext cx="109728" cy="822960"/>
+            <a:off x="548640" y="3383280"/>
+            <a:ext cx="109728" cy="777240"/>
           </a:xfrm>
           <a:prstGeom prst="rect">
             <a:avLst/>
@@ -7230,30 +7394,30 @@
       </p:sp>
       <p:sp>
         <p:nvSpPr>
-          <p:cNvPr id="12" name="Text 9"/>
-          <p:cNvSpPr txBox="1"/>
-          <p:nvPr/>
-        </p:nvSpPr>
-        <p:spPr>
-          <a:xfrm>
-            <a:off x="868680" y="2606040"/>
-            <a:ext cx="10515600" cy="548640"/>
-          </a:xfrm>
-          <a:prstGeom prst="rect">
-            <a:avLst/>
-          </a:prstGeom>
-          <a:noFill/>
-          <a:ln/>
-        </p:spPr>
-        <p:txBody>
-          <a:bodyPr wrap="square" lIns="0" tIns="0" rIns="0" bIns="0" rtlCol="0" anchor="t"/>
-          <a:lstStyle/>
-          <a:p>
-            <a:pPr indent="0" marL="0">
-              <a:buNone/>
-            </a:pPr>
-            <a:r>
-              <a:rPr lang="en-US" sz="1800" b="1" dirty="0">
+          <p:cNvPr id="14" name="Text 11"/>
+          <p:cNvSpPr txBox="1"/>
+          <p:nvPr/>
+        </p:nvSpPr>
+        <p:spPr>
+          <a:xfrm>
+            <a:off x="868680" y="3566160"/>
+            <a:ext cx="10515600" cy="502920"/>
+          </a:xfrm>
+          <a:prstGeom prst="rect">
+            <a:avLst/>
+          </a:prstGeom>
+          <a:noFill/>
+          <a:ln/>
+        </p:spPr>
+        <p:txBody>
+          <a:bodyPr wrap="square" lIns="0" tIns="0" rIns="0" bIns="0" rtlCol="0" anchor="t"/>
+          <a:lstStyle/>
+          <a:p>
+            <a:pPr indent="0" marL="0">
+              <a:buNone/>
+            </a:pPr>
+            <a:r>
+              <a:rPr lang="en-US" sz="1900" b="1" dirty="0">
                 <a:solidFill>
                   <a:srgbClr val="7A5BA6"/>
                 </a:solidFill>
@@ -7261,13 +7425,13 @@
                 <a:ea typeface="Calibri" pitchFamily="34" charset="-122"/>
                 <a:cs typeface="Calibri" pitchFamily="34" charset="-120"/>
               </a:rPr>
-              <a:t>Teil 2:  </a:t>
-            </a:r>
-            <a:pPr indent="0" marL="0">
-              <a:buNone/>
-            </a:pPr>
-            <a:r>
-              <a:rPr lang="en-US" sz="1800" i="1" dirty="0">
+              <a:t>Ziel 2 a:  </a:t>
+            </a:r>
+            <a:pPr indent="0" marL="0">
+              <a:buNone/>
+            </a:pPr>
+            <a:r>
+              <a:rPr lang="en-US" sz="1900" dirty="0">
                 <a:solidFill>
                   <a:srgbClr val="1E2761"/>
                 </a:solidFill>
@@ -7275,21 +7439,393 @@
                 <a:ea typeface="Calibri" pitchFamily="34" charset="-122"/>
                 <a:cs typeface="Calibri" pitchFamily="34" charset="-120"/>
               </a:rPr>
-              <a:t>Ich kann Nebensätze mit Subjunktion erkennen und richtig bilden: Das finite Verb steht am Ende.</a:t>
-            </a:r>
-            <a:endParaRPr lang="en-US" sz="1800" dirty="0"/>
-          </a:p>
-        </p:txBody>
-      </p:sp>
-      <p:sp>
-        <p:nvSpPr>
-          <p:cNvPr id="13" name="Shape 10"/>
+              <a:t>Verbinde: Der Schotte erschrickt. Er sieht die riesige Nase. (als)</a:t>
+            </a:r>
+            <a:endParaRPr lang="en-US" sz="1900" dirty="0"/>
+          </a:p>
+        </p:txBody>
+      </p:sp>
+      <p:sp>
+        <p:nvSpPr>
+          <p:cNvPr id="15" name="Shape 12"/>
           <p:cNvSpPr/>
           <p:nvPr/>
         </p:nvSpPr>
         <p:spPr>
           <a:xfrm>
-            <a:off x="548640" y="3520440"/>
+            <a:off x="548640" y="4297680"/>
+            <a:ext cx="11064240" cy="777240"/>
+          </a:xfrm>
+          <a:prstGeom prst="roundRect">
+            <a:avLst>
+              <a:gd name="adj" fmla="val 9412"/>
+            </a:avLst>
+          </a:prstGeom>
+          <a:solidFill>
+            <a:srgbClr val="F4F7FD"/>
+          </a:solidFill>
+          <a:ln/>
+        </p:spPr>
+      </p:sp>
+      <p:sp>
+        <p:nvSpPr>
+          <p:cNvPr id="16" name="Shape 13"/>
+          <p:cNvSpPr/>
+          <p:nvPr/>
+        </p:nvSpPr>
+        <p:spPr>
+          <a:xfrm>
+            <a:off x="548640" y="4297680"/>
+            <a:ext cx="109728" cy="777240"/>
+          </a:xfrm>
+          <a:prstGeom prst="rect">
+            <a:avLst/>
+          </a:prstGeom>
+          <a:solidFill>
+            <a:srgbClr val="7A5BA6"/>
+          </a:solidFill>
+          <a:ln/>
+        </p:spPr>
+      </p:sp>
+      <p:sp>
+        <p:nvSpPr>
+          <p:cNvPr id="17" name="Text 14"/>
+          <p:cNvSpPr txBox="1"/>
+          <p:nvPr/>
+        </p:nvSpPr>
+        <p:spPr>
+          <a:xfrm>
+            <a:off x="868680" y="4480560"/>
+            <a:ext cx="10515600" cy="502920"/>
+          </a:xfrm>
+          <a:prstGeom prst="rect">
+            <a:avLst/>
+          </a:prstGeom>
+          <a:noFill/>
+          <a:ln/>
+        </p:spPr>
+        <p:txBody>
+          <a:bodyPr wrap="square" lIns="0" tIns="0" rIns="0" bIns="0" rtlCol="0" anchor="t"/>
+          <a:lstStyle/>
+          <a:p>
+            <a:pPr indent="0" marL="0">
+              <a:buNone/>
+            </a:pPr>
+            <a:r>
+              <a:rPr lang="en-US" sz="1900" b="1" dirty="0">
+                <a:solidFill>
+                  <a:srgbClr val="7A5BA6"/>
+                </a:solidFill>
+                <a:latin typeface="Calibri" pitchFamily="34" charset="0"/>
+                <a:ea typeface="Calibri" pitchFamily="34" charset="-122"/>
+                <a:cs typeface="Calibri" pitchFamily="34" charset="-120"/>
+              </a:rPr>
+              <a:t>Ziel 2 b:  </a:t>
+            </a:r>
+            <a:pPr indent="0" marL="0">
+              <a:buNone/>
+            </a:pPr>
+            <a:r>
+              <a:rPr lang="en-US" sz="1900" dirty="0">
+                <a:solidFill>
+                  <a:srgbClr val="1E2761"/>
+                </a:solidFill>
+                <a:latin typeface="Calibri" pitchFamily="34" charset="0"/>
+                <a:ea typeface="Calibri" pitchFamily="34" charset="-122"/>
+                <a:cs typeface="Calibri" pitchFamily="34" charset="-120"/>
+              </a:rPr>
+              <a:t>Richtig oder falsch? Begründe:  „Paddy versteckt sich, weil er hat Angst.“</a:t>
+            </a:r>
+            <a:endParaRPr lang="en-US" sz="1900" dirty="0"/>
+          </a:p>
+        </p:txBody>
+      </p:sp>
+      <p:sp>
+        <p:nvSpPr>
+          <p:cNvPr id="18" name="Shape 15"/>
+          <p:cNvSpPr/>
+          <p:nvPr/>
+        </p:nvSpPr>
+        <p:spPr>
+          <a:xfrm>
+            <a:off x="548640" y="5715000"/>
+            <a:ext cx="11064240" cy="502920"/>
+          </a:xfrm>
+          <a:prstGeom prst="roundRect">
+            <a:avLst>
+              <a:gd name="adj" fmla="val 14545"/>
+            </a:avLst>
+          </a:prstGeom>
+          <a:solidFill>
+            <a:srgbClr val="EAF0FA"/>
+          </a:solidFill>
+          <a:ln/>
+        </p:spPr>
+      </p:sp>
+      <p:sp>
+        <p:nvSpPr>
+          <p:cNvPr id="19" name="Text 16"/>
+          <p:cNvSpPr txBox="1"/>
+          <p:nvPr/>
+        </p:nvSpPr>
+        <p:spPr>
+          <a:xfrm>
+            <a:off x="777240" y="5788152"/>
+            <a:ext cx="10698480" cy="365760"/>
+          </a:xfrm>
+          <a:prstGeom prst="rect">
+            <a:avLst/>
+          </a:prstGeom>
+          <a:noFill/>
+          <a:ln/>
+        </p:spPr>
+        <p:txBody>
+          <a:bodyPr wrap="square" lIns="0" tIns="0" rIns="0" bIns="0" rtlCol="0" anchor="t"/>
+          <a:lstStyle/>
+          <a:p>
+            <a:pPr indent="0" marL="0">
+              <a:buNone/>
+            </a:pPr>
+            <a:r>
+              <a:rPr lang="en-US" sz="1600" b="1" dirty="0">
+                <a:solidFill>
+                  <a:srgbClr val="1E2761"/>
+                </a:solidFill>
+                <a:latin typeface="Calibri" pitchFamily="34" charset="0"/>
+                <a:ea typeface="Calibri" pitchFamily="34" charset="-122"/>
+                <a:cs typeface="Calibri" pitchFamily="34" charset="-120"/>
+              </a:rPr>
+              <a:t>Zeit: </a:t>
+            </a:r>
+            <a:pPr indent="0" marL="0">
+              <a:buNone/>
+            </a:pPr>
+            <a:r>
+              <a:rPr lang="en-US" sz="1600" dirty="0">
+                <a:solidFill>
+                  <a:srgbClr val="1E2761"/>
+                </a:solidFill>
+                <a:latin typeface="Calibri" pitchFamily="34" charset="0"/>
+                <a:ea typeface="Calibri" pitchFamily="34" charset="-122"/>
+                <a:cs typeface="Calibri" pitchFamily="34" charset="-120"/>
+              </a:rPr>
+              <a:t>4 Minuten · allein im Heft, dann Lösung      </a:t>
+            </a:r>
+            <a:pPr indent="0" marL="0">
+              <a:buNone/>
+            </a:pPr>
+            <a:r>
+              <a:rPr lang="en-US" sz="1600" i="1" dirty="0">
+                <a:solidFill>
+                  <a:srgbClr val="5B6B8C"/>
+                </a:solidFill>
+                <a:latin typeface="Calibri" pitchFamily="34" charset="0"/>
+                <a:ea typeface="Calibri" pitchFamily="34" charset="-122"/>
+                <a:cs typeface="Calibri" pitchFamily="34" charset="-120"/>
+              </a:rPr>
+              <a:t>Fertig? Stift hinlegen.</a:t>
+            </a:r>
+            <a:endParaRPr lang="en-US" sz="1600" dirty="0"/>
+          </a:p>
+        </p:txBody>
+      </p:sp>
+    </p:spTree>
+  </p:cSld>
+  <p:clrMapOvr>
+    <a:masterClrMapping/>
+  </p:clrMapOvr>
+</p:sld>
+</file>
+
+<file path=ppt/slides/slide16.xml><?xml version="1.0" encoding="utf-8"?>
+<p:sld xmlns:a="http://schemas.openxmlformats.org/drawingml/2006/main" xmlns:r="http://schemas.openxmlformats.org/officeDocument/2006/relationships" xmlns:p="http://schemas.openxmlformats.org/presentationml/2006/main">
+  <p:cSld name="Slide 16">
+    <p:bg>
+      <p:bgPr>
+        <a:solidFill>
+          <a:srgbClr val="FFFFFF"/>
+        </a:solidFill>
+      </p:bgPr>
+    </p:bg>
+    <p:spTree>
+      <p:nvGrpSpPr>
+        <p:cNvPr id="1" name=""/>
+        <p:cNvGrpSpPr/>
+        <p:nvPr/>
+      </p:nvGrpSpPr>
+      <p:grpSpPr>
+        <a:xfrm>
+          <a:off x="0" y="0"/>
+          <a:ext cx="0" cy="0"/>
+          <a:chOff x="0" y="0"/>
+          <a:chExt cx="0" cy="0"/>
+        </a:xfrm>
+      </p:grpSpPr>
+      <p:sp>
+        <p:nvSpPr>
+          <p:cNvPr id="2" name="Text 0"/>
+          <p:cNvSpPr txBox="1"/>
+          <p:nvPr/>
+        </p:nvSpPr>
+        <p:spPr>
+          <a:xfrm>
+            <a:off x="548640" y="365760"/>
+            <a:ext cx="8229600" cy="274320"/>
+          </a:xfrm>
+          <a:prstGeom prst="rect">
+            <a:avLst/>
+          </a:prstGeom>
+          <a:noFill/>
+          <a:ln/>
+        </p:spPr>
+        <p:txBody>
+          <a:bodyPr wrap="square" lIns="0" tIns="0" rIns="0" bIns="0" rtlCol="0" anchor="t"/>
+          <a:lstStyle/>
+          <a:p>
+            <a:pPr indent="0" marL="0">
+              <a:buNone/>
+            </a:pPr>
+            <a:r>
+              <a:rPr lang="en-US" sz="1200" spc="200" kern="0" dirty="0">
+                <a:solidFill>
+                  <a:srgbClr val="5B6B8C"/>
+                </a:solidFill>
+                <a:latin typeface="Calibri" pitchFamily="34" charset="0"/>
+                <a:ea typeface="Calibri" pitchFamily="34" charset="-122"/>
+                <a:cs typeface="Calibri" pitchFamily="34" charset="-120"/>
+              </a:rPr>
+              <a:t>AUSWERTEN · SELBSTKONTROLLE</a:t>
+            </a:r>
+            <a:endParaRPr lang="en-US" sz="1200" dirty="0"/>
+          </a:p>
+        </p:txBody>
+      </p:sp>
+      <p:sp>
+        <p:nvSpPr>
+          <p:cNvPr id="3" name="Text 1"/>
+          <p:cNvSpPr txBox="1"/>
+          <p:nvPr/>
+        </p:nvSpPr>
+        <p:spPr>
+          <a:xfrm>
+            <a:off x="548640" y="658368"/>
+            <a:ext cx="11064240" cy="640080"/>
+          </a:xfrm>
+          <a:prstGeom prst="rect">
+            <a:avLst/>
+          </a:prstGeom>
+          <a:noFill/>
+          <a:ln/>
+        </p:spPr>
+        <p:txBody>
+          <a:bodyPr wrap="square" lIns="0" tIns="0" rIns="0" bIns="0" rtlCol="0" anchor="t"/>
+          <a:lstStyle/>
+          <a:p>
+            <a:pPr indent="0" marL="0">
+              <a:buNone/>
+            </a:pPr>
+            <a:r>
+              <a:rPr lang="en-US" sz="3200" b="1" dirty="0">
+                <a:solidFill>
+                  <a:srgbClr val="1E2761"/>
+                </a:solidFill>
+                <a:latin typeface="Cambria" pitchFamily="34" charset="0"/>
+                <a:ea typeface="Cambria" pitchFamily="34" charset="-122"/>
+                <a:cs typeface="Cambria" pitchFamily="34" charset="-120"/>
+              </a:rPr>
+              <a:t>Zielcheck – Lösung</a:t>
+            </a:r>
+            <a:endParaRPr lang="en-US" sz="3200" dirty="0"/>
+          </a:p>
+        </p:txBody>
+      </p:sp>
+      <p:sp>
+        <p:nvSpPr>
+          <p:cNvPr id="4" name="Text 2"/>
+          <p:cNvSpPr txBox="1"/>
+          <p:nvPr/>
+        </p:nvSpPr>
+        <p:spPr>
+          <a:xfrm>
+            <a:off x="548640" y="6400800"/>
+            <a:ext cx="6400800" cy="228600"/>
+          </a:xfrm>
+          <a:prstGeom prst="rect">
+            <a:avLst/>
+          </a:prstGeom>
+          <a:noFill/>
+          <a:ln/>
+        </p:spPr>
+        <p:txBody>
+          <a:bodyPr wrap="square" lIns="0" tIns="0" rIns="0" bIns="0" rtlCol="0" anchor="t"/>
+          <a:lstStyle/>
+          <a:p>
+            <a:pPr indent="0" marL="0">
+              <a:buNone/>
+            </a:pPr>
+            <a:r>
+              <a:rPr lang="en-US" sz="1000" dirty="0">
+                <a:solidFill>
+                  <a:srgbClr val="5B6B8C"/>
+                </a:solidFill>
+                <a:latin typeface="Calibri" pitchFamily="34" charset="0"/>
+                <a:ea typeface="Calibri" pitchFamily="34" charset="-122"/>
+                <a:cs typeface="Calibri" pitchFamily="34" charset="-120"/>
+              </a:rPr>
+              <a:t>Teil 2 · Grammatik in der Ballade: Nebensätze mit Subjunktion · Deutsch 7A</a:t>
+            </a:r>
+            <a:endParaRPr lang="en-US" sz="1000" dirty="0"/>
+          </a:p>
+        </p:txBody>
+      </p:sp>
+      <p:sp>
+        <p:nvSpPr>
+          <p:cNvPr id="5" name="Text 3"/>
+          <p:cNvSpPr txBox="1"/>
+          <p:nvPr/>
+        </p:nvSpPr>
+        <p:spPr>
+          <a:xfrm>
+            <a:off x="11155680" y="6400800"/>
+            <a:ext cx="457200" cy="228600"/>
+          </a:xfrm>
+          <a:prstGeom prst="rect">
+            <a:avLst/>
+          </a:prstGeom>
+          <a:noFill/>
+          <a:ln/>
+        </p:spPr>
+        <p:txBody>
+          <a:bodyPr wrap="square" lIns="0" tIns="0" rIns="0" bIns="0" rtlCol="0" anchor="t"/>
+          <a:lstStyle/>
+          <a:p>
+            <a:pPr algn="r" indent="0" marL="0">
+              <a:buNone/>
+            </a:pPr>
+            <a:r>
+              <a:rPr lang="en-US" sz="1000" dirty="0">
+                <a:solidFill>
+                  <a:srgbClr val="5B6B8C"/>
+                </a:solidFill>
+                <a:latin typeface="Calibri" pitchFamily="34" charset="0"/>
+                <a:ea typeface="Calibri" pitchFamily="34" charset="-122"/>
+                <a:cs typeface="Calibri" pitchFamily="34" charset="-120"/>
+              </a:rPr>
+              <a:t>16</a:t>
+            </a:r>
+            <a:endParaRPr lang="en-US" sz="1000" dirty="0"/>
+          </a:p>
+        </p:txBody>
+      </p:sp>
+      <p:sp>
+        <p:nvSpPr>
+          <p:cNvPr id="7" name="Shape 4"/>
+          <p:cNvSpPr/>
+          <p:nvPr/>
+        </p:nvSpPr>
+        <p:spPr>
+          <a:xfrm>
+            <a:off x="548640" y="1645920"/>
             <a:ext cx="11064240" cy="960120"/>
           </a:xfrm>
           <a:prstGeom prst="roundRect">
@@ -7298,37 +7834,152 @@
             </a:avLst>
           </a:prstGeom>
           <a:solidFill>
-            <a:srgbClr val="EAF0FA"/>
+            <a:srgbClr val="F4F7FD"/>
           </a:solidFill>
           <a:ln/>
         </p:spPr>
       </p:sp>
       <p:sp>
         <p:nvSpPr>
-          <p:cNvPr id="14" name="Text 11"/>
-          <p:cNvSpPr txBox="1"/>
-          <p:nvPr/>
-        </p:nvSpPr>
-        <p:spPr>
-          <a:xfrm>
-            <a:off x="822960" y="3630168"/>
-            <a:ext cx="10607040" cy="777240"/>
-          </a:xfrm>
-          <a:prstGeom prst="rect">
-            <a:avLst/>
-          </a:prstGeom>
-          <a:noFill/>
-          <a:ln/>
-        </p:spPr>
-        <p:txBody>
-          <a:bodyPr wrap="square" lIns="0" tIns="0" rIns="0" bIns="0" rtlCol="0" anchor="t"/>
-          <a:lstStyle/>
-          <a:p>
-            <a:pPr indent="0" marL="0">
-              <a:buNone/>
-            </a:pPr>
-            <a:r>
-              <a:rPr lang="en-US" sz="1800" b="1" dirty="0">
+          <p:cNvPr id="8" name="Shape 5"/>
+          <p:cNvSpPr/>
+          <p:nvPr/>
+        </p:nvSpPr>
+        <p:spPr>
+          <a:xfrm>
+            <a:off x="548640" y="1645920"/>
+            <a:ext cx="109728" cy="960120"/>
+          </a:xfrm>
+          <a:prstGeom prst="rect">
+            <a:avLst/>
+          </a:prstGeom>
+          <a:solidFill>
+            <a:srgbClr val="2E9E6B"/>
+          </a:solidFill>
+          <a:ln/>
+        </p:spPr>
+      </p:sp>
+      <p:sp>
+        <p:nvSpPr>
+          <p:cNvPr id="9" name="Text 6"/>
+          <p:cNvSpPr txBox="1"/>
+          <p:nvPr/>
+        </p:nvSpPr>
+        <p:spPr>
+          <a:xfrm>
+            <a:off x="868680" y="1874520"/>
+            <a:ext cx="10515600" cy="594360"/>
+          </a:xfrm>
+          <a:prstGeom prst="rect">
+            <a:avLst/>
+          </a:prstGeom>
+          <a:noFill/>
+          <a:ln/>
+        </p:spPr>
+        <p:txBody>
+          <a:bodyPr wrap="square" lIns="0" tIns="0" rIns="0" bIns="0" rtlCol="0" anchor="t"/>
+          <a:lstStyle/>
+          <a:p>
+            <a:pPr indent="0" marL="0">
+              <a:buNone/>
+            </a:pPr>
+            <a:r>
+              <a:rPr lang="en-US" sz="2000" b="1" dirty="0">
+                <a:solidFill>
+                  <a:srgbClr val="2E9E6B"/>
+                </a:solidFill>
+                <a:latin typeface="Calibri" pitchFamily="34" charset="0"/>
+                <a:ea typeface="Calibri" pitchFamily="34" charset="-122"/>
+                <a:cs typeface="Calibri" pitchFamily="34" charset="-120"/>
+              </a:rPr>
+              <a:t>Ziel 1:  </a:t>
+            </a:r>
+            <a:pPr indent="0" marL="0">
+              <a:buNone/>
+            </a:pPr>
+            <a:r>
+              <a:rPr lang="en-US" sz="2000" dirty="0">
+                <a:solidFill>
+                  <a:srgbClr val="1E2761"/>
+                </a:solidFill>
+                <a:latin typeface="Calibri" pitchFamily="34" charset="0"/>
+                <a:ea typeface="Calibri" pitchFamily="34" charset="-122"/>
+                <a:cs typeface="Calibri" pitchFamily="34" charset="-120"/>
+              </a:rPr>
+              <a:t>Er sieht die riesige Nase des „Babys“ und glaubt, der Vater müsse noch viel größer sein (Str. 8–10).</a:t>
+            </a:r>
+            <a:endParaRPr lang="en-US" sz="2000" dirty="0"/>
+          </a:p>
+        </p:txBody>
+      </p:sp>
+      <p:sp>
+        <p:nvSpPr>
+          <p:cNvPr id="10" name="Shape 7"/>
+          <p:cNvSpPr/>
+          <p:nvPr/>
+        </p:nvSpPr>
+        <p:spPr>
+          <a:xfrm>
+            <a:off x="548640" y="2788920"/>
+            <a:ext cx="11064240" cy="960120"/>
+          </a:xfrm>
+          <a:prstGeom prst="roundRect">
+            <a:avLst>
+              <a:gd name="adj" fmla="val 7619"/>
+            </a:avLst>
+          </a:prstGeom>
+          <a:solidFill>
+            <a:srgbClr val="F4F7FD"/>
+          </a:solidFill>
+          <a:ln/>
+        </p:spPr>
+      </p:sp>
+      <p:sp>
+        <p:nvSpPr>
+          <p:cNvPr id="11" name="Shape 8"/>
+          <p:cNvSpPr/>
+          <p:nvPr/>
+        </p:nvSpPr>
+        <p:spPr>
+          <a:xfrm>
+            <a:off x="548640" y="2788920"/>
+            <a:ext cx="109728" cy="960120"/>
+          </a:xfrm>
+          <a:prstGeom prst="rect">
+            <a:avLst/>
+          </a:prstGeom>
+          <a:solidFill>
+            <a:srgbClr val="7A5BA6"/>
+          </a:solidFill>
+          <a:ln/>
+        </p:spPr>
+      </p:sp>
+      <p:sp>
+        <p:nvSpPr>
+          <p:cNvPr id="12" name="Text 9"/>
+          <p:cNvSpPr txBox="1"/>
+          <p:nvPr/>
+        </p:nvSpPr>
+        <p:spPr>
+          <a:xfrm>
+            <a:off x="868680" y="3017520"/>
+            <a:ext cx="10515600" cy="594360"/>
+          </a:xfrm>
+          <a:prstGeom prst="rect">
+            <a:avLst/>
+          </a:prstGeom>
+          <a:noFill/>
+          <a:ln/>
+        </p:spPr>
+        <p:txBody>
+          <a:bodyPr wrap="square" lIns="0" tIns="0" rIns="0" bIns="0" rtlCol="0" anchor="t"/>
+          <a:lstStyle/>
+          <a:p>
+            <a:pPr indent="0" marL="0">
+              <a:buNone/>
+            </a:pPr>
+            <a:r>
+              <a:rPr lang="en-US" sz="2000" b="1" dirty="0">
                 <a:solidFill>
                   <a:srgbClr val="7A5BA6"/>
                 </a:solidFill>
@@ -7336,13 +7987,13 @@
                 <a:ea typeface="Calibri" pitchFamily="34" charset="-122"/>
                 <a:cs typeface="Calibri" pitchFamily="34" charset="-120"/>
               </a:rPr>
-              <a:t>* Forscherfrage: </a:t>
-            </a:r>
-            <a:pPr indent="0" marL="0">
-              <a:buNone/>
-            </a:pPr>
-            <a:r>
-              <a:rPr lang="en-US" sz="1800" dirty="0">
+              <a:t>Ziel 2 a:  </a:t>
+            </a:r>
+            <a:pPr indent="0" marL="0">
+              <a:buNone/>
+            </a:pPr>
+            <a:r>
+              <a:rPr lang="en-US" sz="2000" dirty="0">
                 <a:solidFill>
                   <a:srgbClr val="1E2761"/>
                 </a:solidFill>
@@ -7350,11 +8001,53 @@
                 <a:ea typeface="Calibri" pitchFamily="34" charset="-122"/>
                 <a:cs typeface="Calibri" pitchFamily="34" charset="-120"/>
               </a:rPr>
-              <a:t>In Strophe 3 steht: „Und als er stapfte durch den Sund“. Was ist hier anders – und warum macht der Dichter das?</a:t>
-            </a:r>
-            <a:endParaRPr lang="en-US" sz="1800" dirty="0"/>
-          </a:p>
-        </p:txBody>
+              <a:t>Der Schotte erschrickt, als er die riesige Nase sieht.</a:t>
+            </a:r>
+            <a:endParaRPr lang="en-US" sz="2000" dirty="0"/>
+          </a:p>
+        </p:txBody>
+      </p:sp>
+      <p:sp>
+        <p:nvSpPr>
+          <p:cNvPr id="13" name="Shape 10"/>
+          <p:cNvSpPr/>
+          <p:nvPr/>
+        </p:nvSpPr>
+        <p:spPr>
+          <a:xfrm>
+            <a:off x="548640" y="3931920"/>
+            <a:ext cx="11064240" cy="960120"/>
+          </a:xfrm>
+          <a:prstGeom prst="roundRect">
+            <a:avLst>
+              <a:gd name="adj" fmla="val 7619"/>
+            </a:avLst>
+          </a:prstGeom>
+          <a:solidFill>
+            <a:srgbClr val="F4F7FD"/>
+          </a:solidFill>
+          <a:ln/>
+        </p:spPr>
+      </p:sp>
+      <p:sp>
+        <p:nvSpPr>
+          <p:cNvPr id="14" name="Shape 11"/>
+          <p:cNvSpPr/>
+          <p:nvPr/>
+        </p:nvSpPr>
+        <p:spPr>
+          <a:xfrm>
+            <a:off x="548640" y="3931920"/>
+            <a:ext cx="109728" cy="960120"/>
+          </a:xfrm>
+          <a:prstGeom prst="rect">
+            <a:avLst/>
+          </a:prstGeom>
+          <a:solidFill>
+            <a:srgbClr val="7A5BA6"/>
+          </a:solidFill>
+          <a:ln/>
+        </p:spPr>
       </p:sp>
       <p:sp>
         <p:nvSpPr>
@@ -7364,8 +8057,61 @@
         </p:nvSpPr>
         <p:spPr>
           <a:xfrm>
-            <a:off x="548640" y="4846320"/>
-            <a:ext cx="11064240" cy="548640"/>
+            <a:off x="868680" y="4160520"/>
+            <a:ext cx="10515600" cy="594360"/>
+          </a:xfrm>
+          <a:prstGeom prst="rect">
+            <a:avLst/>
+          </a:prstGeom>
+          <a:noFill/>
+          <a:ln/>
+        </p:spPr>
+        <p:txBody>
+          <a:bodyPr wrap="square" lIns="0" tIns="0" rIns="0" bIns="0" rtlCol="0" anchor="t"/>
+          <a:lstStyle/>
+          <a:p>
+            <a:pPr indent="0" marL="0">
+              <a:buNone/>
+            </a:pPr>
+            <a:r>
+              <a:rPr lang="en-US" sz="2000" b="1" dirty="0">
+                <a:solidFill>
+                  <a:srgbClr val="7A5BA6"/>
+                </a:solidFill>
+                <a:latin typeface="Calibri" pitchFamily="34" charset="0"/>
+                <a:ea typeface="Calibri" pitchFamily="34" charset="-122"/>
+                <a:cs typeface="Calibri" pitchFamily="34" charset="-120"/>
+              </a:rPr>
+              <a:t>Ziel 2 b:  </a:t>
+            </a:r>
+            <a:pPr indent="0" marL="0">
+              <a:buNone/>
+            </a:pPr>
+            <a:r>
+              <a:rPr lang="en-US" sz="2000" dirty="0">
+                <a:solidFill>
+                  <a:srgbClr val="1E2761"/>
+                </a:solidFill>
+                <a:latin typeface="Calibri" pitchFamily="34" charset="0"/>
+                <a:ea typeface="Calibri" pitchFamily="34" charset="-122"/>
+                <a:cs typeface="Calibri" pitchFamily="34" charset="-120"/>
+              </a:rPr>
+              <a:t>Falsch: Im Nebensatz steht das finite Verb am Ende → …, weil er Angst hat.</a:t>
+            </a:r>
+            <a:endParaRPr lang="en-US" sz="2000" dirty="0"/>
+          </a:p>
+        </p:txBody>
+      </p:sp>
+      <p:sp>
+        <p:nvSpPr>
+          <p:cNvPr id="16" name="Text 13"/>
+          <p:cNvSpPr txBox="1"/>
+          <p:nvPr/>
+        </p:nvSpPr>
+        <p:spPr>
+          <a:xfrm>
+            <a:off x="548640" y="5257800"/>
+            <a:ext cx="11064240" cy="457200"/>
           </a:xfrm>
           <a:prstGeom prst="rect">
             <a:avLst/>
@@ -7381,17 +8127,17 @@
               <a:buNone/>
             </a:pPr>
             <a:r>
-              <a:rPr lang="en-US" sz="2600" b="1" dirty="0">
+              <a:rPr lang="en-US" sz="2000" b="1" dirty="0">
                 <a:solidFill>
                   <a:srgbClr val="1E2761"/>
                 </a:solidFill>
-                <a:latin typeface="Cambria" pitchFamily="34" charset="0"/>
-                <a:ea typeface="Cambria" pitchFamily="34" charset="-122"/>
-                <a:cs typeface="Cambria" pitchFamily="34" charset="-120"/>
-              </a:rPr>
-              <a:t>Schreibe ins Heft:  Heute habe ich gelernt, …</a:t>
-            </a:r>
-            <a:endParaRPr lang="en-US" sz="2600" dirty="0"/>
+                <a:latin typeface="Calibri" pitchFamily="34" charset="0"/>
+                <a:ea typeface="Calibri" pitchFamily="34" charset="-122"/>
+                <a:cs typeface="Calibri" pitchFamily="34" charset="-120"/>
+              </a:rPr>
+              <a:t>Verbessere mit Grün. Alles richtig? Dann hast du beide Ziele erreicht.</a:t>
+            </a:r>
+            <a:endParaRPr lang="en-US" sz="2000" dirty="0"/>
           </a:p>
         </p:txBody>
       </p:sp>
@@ -8158,7 +8904,7 @@
                 <a:ea typeface="Calibri" pitchFamily="34" charset="-122"/>
                 <a:cs typeface="Calibri" pitchFamily="34" charset="-120"/>
               </a:rPr>
-              <a:t>* = nur, wenn die Zeit reicht. Am Ende: „Heute habe ich gelernt, …“</a:t>
+              <a:t>* = nur, wenn die Zeit reicht. Am Ende: Zielcheck – zwei kurze Aufgaben zu unseren Zielen.</a:t>
             </a:r>
             <a:endParaRPr lang="en-US" sz="1400" dirty="0"/>
           </a:p>
@@ -9819,7 +10565,7 @@
                 <a:ea typeface="Cambria" pitchFamily="34" charset="-122"/>
                 <a:cs typeface="Cambria" pitchFamily="34" charset="-120"/>
               </a:rPr>
-              <a:t>Vergleich in der Kreide-Kette</a:t>
+              <a:t>Prüf-Kette: Stimmt die Antwort?</a:t>
             </a:r>
             <a:endParaRPr lang="en-US" sz="3200" dirty="0"/>
           </a:p>
@@ -9905,30 +10651,89 @@
       </p:sp>
       <p:sp>
         <p:nvSpPr>
-          <p:cNvPr id="7" name="Text 4"/>
-          <p:cNvSpPr txBox="1"/>
+          <p:cNvPr id="7" name="Shape 4"/>
+          <p:cNvSpPr/>
           <p:nvPr/>
         </p:nvSpPr>
         <p:spPr>
           <a:xfrm>
             <a:off x="548640" y="1645920"/>
-            <a:ext cx="11064240" cy="548640"/>
-          </a:xfrm>
-          <a:prstGeom prst="rect">
-            <a:avLst/>
-          </a:prstGeom>
-          <a:noFill/>
-          <a:ln/>
-        </p:spPr>
-        <p:txBody>
-          <a:bodyPr wrap="square" lIns="0" tIns="0" rIns="0" bIns="0" rtlCol="0" anchor="t"/>
-          <a:lstStyle/>
-          <a:p>
-            <a:pPr indent="0" marL="0">
-              <a:buNone/>
-            </a:pPr>
-            <a:r>
-              <a:rPr lang="en-US" sz="2400" b="1" dirty="0">
+            <a:ext cx="457200" cy="457200"/>
+          </a:xfrm>
+          <a:prstGeom prst="ellipse">
+            <a:avLst/>
+          </a:prstGeom>
+          <a:solidFill>
+            <a:srgbClr val="2E9E6B"/>
+          </a:solidFill>
+          <a:ln/>
+        </p:spPr>
+      </p:sp>
+      <p:sp>
+        <p:nvSpPr>
+          <p:cNvPr id="8" name="Text 5"/>
+          <p:cNvSpPr txBox="1"/>
+          <p:nvPr/>
+        </p:nvSpPr>
+        <p:spPr>
+          <a:xfrm>
+            <a:off x="548640" y="1645920"/>
+            <a:ext cx="457200" cy="457200"/>
+          </a:xfrm>
+          <a:prstGeom prst="rect">
+            <a:avLst/>
+          </a:prstGeom>
+          <a:noFill/>
+          <a:ln/>
+        </p:spPr>
+        <p:txBody>
+          <a:bodyPr wrap="square" lIns="0" tIns="0" rIns="0" bIns="0" rtlCol="0" anchor="ctr"/>
+          <a:lstStyle/>
+          <a:p>
+            <a:pPr algn="ctr" indent="0" marL="0">
+              <a:buNone/>
+            </a:pPr>
+            <a:r>
+              <a:rPr lang="en-US" sz="1600" b="1" dirty="0">
+                <a:solidFill>
+                  <a:srgbClr val="FFFFFF"/>
+                </a:solidFill>
+                <a:latin typeface="Calibri" pitchFamily="34" charset="0"/>
+                <a:ea typeface="Calibri" pitchFamily="34" charset="-122"/>
+                <a:cs typeface="Calibri" pitchFamily="34" charset="-120"/>
+              </a:rPr>
+              <a:t>1</a:t>
+            </a:r>
+            <a:endParaRPr lang="en-US" sz="1600" dirty="0"/>
+          </a:p>
+        </p:txBody>
+      </p:sp>
+      <p:sp>
+        <p:nvSpPr>
+          <p:cNvPr id="9" name="Text 6"/>
+          <p:cNvSpPr txBox="1"/>
+          <p:nvPr/>
+        </p:nvSpPr>
+        <p:spPr>
+          <a:xfrm>
+            <a:off x="1188720" y="1682496"/>
+            <a:ext cx="10332720" cy="640080"/>
+          </a:xfrm>
+          <a:prstGeom prst="rect">
+            <a:avLst/>
+          </a:prstGeom>
+          <a:noFill/>
+          <a:ln/>
+        </p:spPr>
+        <p:txBody>
+          <a:bodyPr wrap="square" lIns="0" tIns="0" rIns="0" bIns="0" rtlCol="0" anchor="t"/>
+          <a:lstStyle/>
+          <a:p>
+            <a:pPr indent="0" marL="0">
+              <a:buNone/>
+            </a:pPr>
+            <a:r>
+              <a:rPr lang="en-US" sz="2100" b="1" dirty="0">
                 <a:solidFill>
                   <a:srgbClr val="1E2761"/>
                 </a:solidFill>
@@ -9936,38 +10741,97 @@
                 <a:ea typeface="Calibri" pitchFamily="34" charset="-122"/>
                 <a:cs typeface="Calibri" pitchFamily="34" charset="-120"/>
               </a:rPr>
-              <a:t>Wer drankommt, schreibt die Antwort in Stichworten mit Strophe an die Tafel.</a:t>
-            </a:r>
-            <a:endParaRPr lang="en-US" sz="2400" dirty="0"/>
-          </a:p>
-        </p:txBody>
-      </p:sp>
-      <p:sp>
-        <p:nvSpPr>
-          <p:cNvPr id="8" name="Text 5"/>
-          <p:cNvSpPr txBox="1"/>
-          <p:nvPr/>
-        </p:nvSpPr>
-        <p:spPr>
-          <a:xfrm>
-            <a:off x="548640" y="2286000"/>
-            <a:ext cx="11064240" cy="548640"/>
-          </a:xfrm>
-          <a:prstGeom prst="rect">
-            <a:avLst/>
-          </a:prstGeom>
-          <a:noFill/>
-          <a:ln/>
-        </p:spPr>
-        <p:txBody>
-          <a:bodyPr wrap="square" lIns="0" tIns="0" rIns="0" bIns="0" rtlCol="0" anchor="t"/>
-          <a:lstStyle/>
-          <a:p>
-            <a:pPr indent="0" marL="0">
-              <a:buNone/>
-            </a:pPr>
-            <a:r>
-              <a:rPr lang="en-US" sz="2400" dirty="0">
+              <a:t>Wer drankommt, prüft zuerst die Antwort davor:  ✓ oder ✗  +  Begründung in Stichworten.</a:t>
+            </a:r>
+            <a:endParaRPr lang="en-US" sz="2100" dirty="0"/>
+          </a:p>
+        </p:txBody>
+      </p:sp>
+      <p:sp>
+        <p:nvSpPr>
+          <p:cNvPr id="10" name="Shape 7"/>
+          <p:cNvSpPr/>
+          <p:nvPr/>
+        </p:nvSpPr>
+        <p:spPr>
+          <a:xfrm>
+            <a:off x="548640" y="2423160"/>
+            <a:ext cx="457200" cy="457200"/>
+          </a:xfrm>
+          <a:prstGeom prst="ellipse">
+            <a:avLst/>
+          </a:prstGeom>
+          <a:solidFill>
+            <a:srgbClr val="2E9E6B"/>
+          </a:solidFill>
+          <a:ln/>
+        </p:spPr>
+      </p:sp>
+      <p:sp>
+        <p:nvSpPr>
+          <p:cNvPr id="11" name="Text 8"/>
+          <p:cNvSpPr txBox="1"/>
+          <p:nvPr/>
+        </p:nvSpPr>
+        <p:spPr>
+          <a:xfrm>
+            <a:off x="548640" y="2423160"/>
+            <a:ext cx="457200" cy="457200"/>
+          </a:xfrm>
+          <a:prstGeom prst="rect">
+            <a:avLst/>
+          </a:prstGeom>
+          <a:noFill/>
+          <a:ln/>
+        </p:spPr>
+        <p:txBody>
+          <a:bodyPr wrap="square" lIns="0" tIns="0" rIns="0" bIns="0" rtlCol="0" anchor="ctr"/>
+          <a:lstStyle/>
+          <a:p>
+            <a:pPr algn="ctr" indent="0" marL="0">
+              <a:buNone/>
+            </a:pPr>
+            <a:r>
+              <a:rPr lang="en-US" sz="1600" b="1" dirty="0">
+                <a:solidFill>
+                  <a:srgbClr val="FFFFFF"/>
+                </a:solidFill>
+                <a:latin typeface="Calibri" pitchFamily="34" charset="0"/>
+                <a:ea typeface="Calibri" pitchFamily="34" charset="-122"/>
+                <a:cs typeface="Calibri" pitchFamily="34" charset="-120"/>
+              </a:rPr>
+              <a:t>2</a:t>
+            </a:r>
+            <a:endParaRPr lang="en-US" sz="1600" dirty="0"/>
+          </a:p>
+        </p:txBody>
+      </p:sp>
+      <p:sp>
+        <p:nvSpPr>
+          <p:cNvPr id="12" name="Text 9"/>
+          <p:cNvSpPr txBox="1"/>
+          <p:nvPr/>
+        </p:nvSpPr>
+        <p:spPr>
+          <a:xfrm>
+            <a:off x="1188720" y="2459736"/>
+            <a:ext cx="10332720" cy="640080"/>
+          </a:xfrm>
+          <a:prstGeom prst="rect">
+            <a:avLst/>
+          </a:prstGeom>
+          <a:noFill/>
+          <a:ln/>
+        </p:spPr>
+        <p:txBody>
+          <a:bodyPr wrap="square" lIns="0" tIns="0" rIns="0" bIns="0" rtlCol="0" anchor="t"/>
+          <a:lstStyle/>
+          <a:p>
+            <a:pPr indent="0" marL="0">
+              <a:buNone/>
+            </a:pPr>
+            <a:r>
+              <a:rPr lang="en-US" sz="2100" b="1" dirty="0">
                 <a:solidFill>
                   <a:srgbClr val="1E2761"/>
                 </a:solidFill>
@@ -9975,26 +10839,124 @@
                 <a:ea typeface="Calibri" pitchFamily="34" charset="-122"/>
                 <a:cs typeface="Calibri" pitchFamily="34" charset="-120"/>
               </a:rPr>
-              <a:t>Alle anderen prüfen mit und verbessern im Heft mit Grün.</a:t>
-            </a:r>
-            <a:endParaRPr lang="en-US" sz="2400" dirty="0"/>
-          </a:p>
-        </p:txBody>
-      </p:sp>
-      <p:sp>
-        <p:nvSpPr>
-          <p:cNvPr id="9" name="Shape 6"/>
+              <a:t>Dann schreibt er die nächste Antwort in Stichworten mit Strophe an.</a:t>
+            </a:r>
+            <a:endParaRPr lang="en-US" sz="2100" dirty="0"/>
+          </a:p>
+        </p:txBody>
+      </p:sp>
+      <p:sp>
+        <p:nvSpPr>
+          <p:cNvPr id="13" name="Shape 10"/>
           <p:cNvSpPr/>
           <p:nvPr/>
         </p:nvSpPr>
         <p:spPr>
           <a:xfrm>
             <a:off x="548640" y="3200400"/>
-            <a:ext cx="11064240" cy="1463040"/>
+            <a:ext cx="457200" cy="457200"/>
+          </a:xfrm>
+          <a:prstGeom prst="ellipse">
+            <a:avLst/>
+          </a:prstGeom>
+          <a:solidFill>
+            <a:srgbClr val="2E9E6B"/>
+          </a:solidFill>
+          <a:ln/>
+        </p:spPr>
+      </p:sp>
+      <p:sp>
+        <p:nvSpPr>
+          <p:cNvPr id="14" name="Text 11"/>
+          <p:cNvSpPr txBox="1"/>
+          <p:nvPr/>
+        </p:nvSpPr>
+        <p:spPr>
+          <a:xfrm>
+            <a:off x="548640" y="3200400"/>
+            <a:ext cx="457200" cy="457200"/>
+          </a:xfrm>
+          <a:prstGeom prst="rect">
+            <a:avLst/>
+          </a:prstGeom>
+          <a:noFill/>
+          <a:ln/>
+        </p:spPr>
+        <p:txBody>
+          <a:bodyPr wrap="square" lIns="0" tIns="0" rIns="0" bIns="0" rtlCol="0" anchor="ctr"/>
+          <a:lstStyle/>
+          <a:p>
+            <a:pPr algn="ctr" indent="0" marL="0">
+              <a:buNone/>
+            </a:pPr>
+            <a:r>
+              <a:rPr lang="en-US" sz="1600" b="1" dirty="0">
+                <a:solidFill>
+                  <a:srgbClr val="FFFFFF"/>
+                </a:solidFill>
+                <a:latin typeface="Calibri" pitchFamily="34" charset="0"/>
+                <a:ea typeface="Calibri" pitchFamily="34" charset="-122"/>
+                <a:cs typeface="Calibri" pitchFamily="34" charset="-120"/>
+              </a:rPr>
+              <a:t>3</a:t>
+            </a:r>
+            <a:endParaRPr lang="en-US" sz="1600" dirty="0"/>
+          </a:p>
+        </p:txBody>
+      </p:sp>
+      <p:sp>
+        <p:nvSpPr>
+          <p:cNvPr id="15" name="Text 12"/>
+          <p:cNvSpPr txBox="1"/>
+          <p:nvPr/>
+        </p:nvSpPr>
+        <p:spPr>
+          <a:xfrm>
+            <a:off x="1188720" y="3236976"/>
+            <a:ext cx="10332720" cy="640080"/>
+          </a:xfrm>
+          <a:prstGeom prst="rect">
+            <a:avLst/>
+          </a:prstGeom>
+          <a:noFill/>
+          <a:ln/>
+        </p:spPr>
+        <p:txBody>
+          <a:bodyPr wrap="square" lIns="0" tIns="0" rIns="0" bIns="0" rtlCol="0" anchor="t"/>
+          <a:lstStyle/>
+          <a:p>
+            <a:pPr indent="0" marL="0">
+              <a:buNone/>
+            </a:pPr>
+            <a:r>
+              <a:rPr lang="en-US" sz="2100" dirty="0">
+                <a:solidFill>
+                  <a:srgbClr val="1E2761"/>
+                </a:solidFill>
+                <a:latin typeface="Calibri" pitchFamily="34" charset="0"/>
+                <a:ea typeface="Calibri" pitchFamily="34" charset="-122"/>
+                <a:cs typeface="Calibri" pitchFamily="34" charset="-120"/>
+              </a:rPr>
+              <a:t>Alle anderen vergleichen mit ihrem Heft und verbessern mit Grün.</a:t>
+            </a:r>
+            <a:endParaRPr lang="en-US" sz="2100" dirty="0"/>
+          </a:p>
+        </p:txBody>
+      </p:sp>
+      <p:sp>
+        <p:nvSpPr>
+          <p:cNvPr id="16" name="Shape 13"/>
+          <p:cNvSpPr/>
+          <p:nvPr/>
+        </p:nvSpPr>
+        <p:spPr>
+          <a:xfrm>
+            <a:off x="548640" y="4206240"/>
+            <a:ext cx="11064240" cy="914400"/>
           </a:xfrm>
           <a:prstGeom prst="roundRect">
             <a:avLst>
-              <a:gd name="adj" fmla="val 5000"/>
+              <a:gd name="adj" fmla="val 8000"/>
             </a:avLst>
           </a:prstGeom>
           <a:solidFill>
@@ -10005,30 +10967,30 @@
       </p:sp>
       <p:sp>
         <p:nvSpPr>
-          <p:cNvPr id="10" name="Text 7"/>
-          <p:cNvSpPr txBox="1"/>
-          <p:nvPr/>
-        </p:nvSpPr>
-        <p:spPr>
-          <a:xfrm>
-            <a:off x="822960" y="3429000"/>
-            <a:ext cx="10515600" cy="1097280"/>
-          </a:xfrm>
-          <a:prstGeom prst="rect">
-            <a:avLst/>
-          </a:prstGeom>
-          <a:noFill/>
-          <a:ln/>
-        </p:spPr>
-        <p:txBody>
-          <a:bodyPr wrap="square" lIns="0" tIns="0" rIns="0" bIns="0" rtlCol="0" anchor="t"/>
-          <a:lstStyle/>
-          <a:p>
-            <a:pPr indent="0" marL="0">
-              <a:buNone/>
-            </a:pPr>
-            <a:r>
-              <a:rPr lang="en-US" sz="2000" b="1" dirty="0">
+          <p:cNvPr id="17" name="Text 14"/>
+          <p:cNvSpPr txBox="1"/>
+          <p:nvPr/>
+        </p:nvSpPr>
+        <p:spPr>
+          <a:xfrm>
+            <a:off x="822960" y="4434840"/>
+            <a:ext cx="10515600" cy="548640"/>
+          </a:xfrm>
+          <a:prstGeom prst="rect">
+            <a:avLst/>
+          </a:prstGeom>
+          <a:noFill/>
+          <a:ln/>
+        </p:spPr>
+        <p:txBody>
+          <a:bodyPr wrap="square" lIns="0" tIns="0" rIns="0" bIns="0" rtlCol="0" anchor="t"/>
+          <a:lstStyle/>
+          <a:p>
+            <a:pPr indent="0" marL="0">
+              <a:buNone/>
+            </a:pPr>
+            <a:r>
+              <a:rPr lang="en-US" sz="1800" b="1" dirty="0">
                 <a:solidFill>
                   <a:srgbClr val="2E9E6B"/>
                 </a:solidFill>
@@ -10036,13 +10998,13 @@
                 <a:ea typeface="Calibri" pitchFamily="34" charset="-122"/>
                 <a:cs typeface="Calibri" pitchFamily="34" charset="-120"/>
               </a:rPr>
-              <a:t>Teil 1 – Ziel erreicht?  </a:t>
-            </a:r>
-            <a:pPr indent="0" marL="0">
-              <a:buNone/>
-            </a:pPr>
-            <a:r>
-              <a:rPr lang="en-US" sz="2000" i="1" dirty="0">
+              <a:t>Beispiel:  </a:t>
+            </a:r>
+            <a:pPr indent="0" marL="0">
+              <a:buNone/>
+            </a:pPr>
+            <a:r>
+              <a:rPr lang="en-US" sz="1800" dirty="0">
                 <a:solidFill>
                   <a:srgbClr val="1E2761"/>
                 </a:solidFill>
@@ -10050,9 +11012,9 @@
                 <a:ea typeface="Calibri" pitchFamily="34" charset="-122"/>
                 <a:cs typeface="Calibri" pitchFamily="34" charset="-120"/>
               </a:rPr>
-              <a:t>Ich kann Fragen zum Inhalt der Ballade mit Textbeleg beantworten.</a:t>
-            </a:r>
-            <a:endParaRPr lang="en-US" sz="2000" dirty="0"/>
+              <a:t>✓ – Strophe 1 stimmt, alle Merkmale genannt   ·   ✗ – die List steht in Str. 5–10, nicht in Str. 2</a:t>
+            </a:r>
+            <a:endParaRPr lang="en-US" sz="1800" dirty="0"/>
           </a:p>
         </p:txBody>
       </p:sp>

</xml_diff>

<commit_message>
„Sprachtraining“ statt „Grammatik“ im Material für Mi 4.11.; Begriff in CLAUDE.md festgehalten
Co-Authored-By: Claude Opus 5.5 <noreply@anthropic.com>
Claude-Session: https://claude.ai/code/session_01KXvLXHMYPnCyEbMRgNaaYs
</commit_message>
<xml_diff>
--- a/Deutsch_7A/Balladen/Woche2/Mittwoch_04-11_Deutsch_7A.pptx
+++ b/Deutsch_7A/Balladen/Woche2/Mittwoch_04-11_Deutsch_7A.pptx
@@ -2344,7 +2344,7 @@
                 <a:ea typeface="Cambria" pitchFamily="34" charset="-122"/>
                 <a:cs typeface="Cambria" pitchFamily="34" charset="-120"/>
               </a:rPr>
-              <a:t>Deutsch 7A – Paddy Fingal: Inhalt und Grammatik</a:t>
+              <a:t>Deutsch 7A – Paddy Fingal: Inhalt und Sprachtraining</a:t>
             </a:r>
             <a:endParaRPr lang="en-US" sz="3800" dirty="0"/>
           </a:p>
@@ -2466,7 +2466,7 @@
                 <a:ea typeface="Calibri" pitchFamily="34" charset="-122"/>
                 <a:cs typeface="Calibri" pitchFamily="34" charset="-120"/>
               </a:rPr>
-              <a:t>2  Grammatik in der Ballade</a:t>
+              <a:t>2  Sprachtraining an der Ballade</a:t>
             </a:r>
             <a:endParaRPr lang="en-US" sz="2000" dirty="0"/>
           </a:p>
@@ -2615,7 +2615,7 @@
                 <a:ea typeface="Calibri" pitchFamily="34" charset="-122"/>
                 <a:cs typeface="Calibri" pitchFamily="34" charset="-120"/>
               </a:rPr>
-              <a:t>Teil 2 · Grammatik in der Ballade: Nebensätze mit Subjunktion · Deutsch 7A</a:t>
+              <a:t>Teil 2 · Sprachtraining: Nebensätze mit Subjunktion · Deutsch 7A</a:t>
             </a:r>
             <a:endParaRPr lang="en-US" sz="1000" dirty="0"/>
           </a:p>
@@ -3542,7 +3542,7 @@
                 <a:ea typeface="Calibri" pitchFamily="34" charset="-122"/>
                 <a:cs typeface="Calibri" pitchFamily="34" charset="-120"/>
               </a:rPr>
-              <a:t>Teil 2 · Grammatik in der Ballade: Nebensätze mit Subjunktion · Deutsch 7A</a:t>
+              <a:t>Teil 2 · Sprachtraining: Nebensätze mit Subjunktion · Deutsch 7A</a:t>
             </a:r>
             <a:endParaRPr lang="en-US" sz="1000" dirty="0"/>
           </a:p>
@@ -4382,7 +4382,7 @@
                 <a:ea typeface="Calibri" pitchFamily="34" charset="-122"/>
                 <a:cs typeface="Calibri" pitchFamily="34" charset="-120"/>
               </a:rPr>
-              <a:t>Teil 2 · Grammatik in der Ballade: Nebensätze mit Subjunktion · Deutsch 7A</a:t>
+              <a:t>Teil 2 · Sprachtraining: Nebensätze mit Subjunktion · Deutsch 7A</a:t>
             </a:r>
             <a:endParaRPr lang="en-US" sz="1000" dirty="0"/>
           </a:p>
@@ -5677,7 +5677,7 @@
                 <a:ea typeface="Calibri" pitchFamily="34" charset="-122"/>
                 <a:cs typeface="Calibri" pitchFamily="34" charset="-120"/>
               </a:rPr>
-              <a:t>Teil 2 · Grammatik in der Ballade: Nebensätze mit Subjunktion · Deutsch 7A</a:t>
+              <a:t>Teil 2 · Sprachtraining: Nebensätze mit Subjunktion · Deutsch 7A</a:t>
             </a:r>
             <a:endParaRPr lang="en-US" sz="1000" dirty="0"/>
           </a:p>
@@ -6514,7 +6514,7 @@
                 <a:ea typeface="Calibri" pitchFamily="34" charset="-122"/>
                 <a:cs typeface="Calibri" pitchFamily="34" charset="-120"/>
               </a:rPr>
-              <a:t>Teil 2 · Grammatik in der Ballade: Nebensätze mit Subjunktion · Deutsch 7A</a:t>
+              <a:t>Teil 2 · Sprachtraining: Nebensätze mit Subjunktion · Deutsch 7A</a:t>
             </a:r>
             <a:endParaRPr lang="en-US" sz="1000" dirty="0"/>
           </a:p>
@@ -7135,7 +7135,7 @@
                 <a:ea typeface="Calibri" pitchFamily="34" charset="-122"/>
                 <a:cs typeface="Calibri" pitchFamily="34" charset="-120"/>
               </a:rPr>
-              <a:t>Teil 2 · Grammatik in der Ballade: Nebensätze mit Subjunktion · Deutsch 7A</a:t>
+              <a:t>Teil 2 · Sprachtraining: Nebensätze mit Subjunktion · Deutsch 7A</a:t>
             </a:r>
             <a:endParaRPr lang="en-US" sz="1000" dirty="0"/>
           </a:p>
@@ -7772,7 +7772,7 @@
                 <a:ea typeface="Calibri" pitchFamily="34" charset="-122"/>
                 <a:cs typeface="Calibri" pitchFamily="34" charset="-120"/>
               </a:rPr>
-              <a:t>Teil 2 · Grammatik in der Ballade: Nebensätze mit Subjunktion · Deutsch 7A</a:t>
+              <a:t>Teil 2 · Sprachtraining: Nebensätze mit Subjunktion · Deutsch 7A</a:t>
             </a:r>
             <a:endParaRPr lang="en-US" sz="1000" dirty="0"/>
           </a:p>
@@ -8734,7 +8734,7 @@
                 <a:ea typeface="Cambria" pitchFamily="34" charset="-122"/>
                 <a:cs typeface="Cambria" pitchFamily="34" charset="-120"/>
               </a:rPr>
-              <a:t>Grammatik in der Ballade: Nebensätze mit Subjunktion</a:t>
+              <a:t>Sprachtraining: Nebensätze mit Subjunktion</a:t>
             </a:r>
             <a:endParaRPr lang="en-US" sz="2200" dirty="0"/>
           </a:p>
@@ -11830,7 +11830,7 @@
                 <a:ea typeface="Cambria" pitchFamily="34" charset="-122"/>
                 <a:cs typeface="Cambria" pitchFamily="34" charset="-120"/>
               </a:rPr>
-              <a:t>Grammatik in der Ballade</a:t>
+              <a:t>Sprachtraining an der Ballade</a:t>
             </a:r>
             <a:endParaRPr lang="en-US" sz="4000" dirty="0"/>
           </a:p>
@@ -12018,7 +12018,7 @@
                 <a:ea typeface="Calibri" pitchFamily="34" charset="-122"/>
                 <a:cs typeface="Calibri" pitchFamily="34" charset="-120"/>
               </a:rPr>
-              <a:t>Teil 2 · Grammatik in der Ballade: Nebensätze mit Subjunktion · Deutsch 7A</a:t>
+              <a:t>Teil 2 · Sprachtraining: Nebensätze mit Subjunktion · Deutsch 7A</a:t>
             </a:r>
             <a:endParaRPr lang="en-US" sz="1000" dirty="0"/>
           </a:p>

</xml_diff>